<commit_message>
Mark Aditi's tasks complete in the deck and results brief
Aditi's AT1-AT3 (results assembler with schema hard-fail, three confirmed
report bugs fixed, receipts pack) were completed in the ast-asr checkout
alongside this session's work. Updates slide 7's contribution table
(all four members now Complete), adds a results-assembly line to slide
6's module list, and expands RESULTS_BRIEF.md with what was built, where,
and how it was verified against the six audit summaries.

Co-authored-by: kaustubhc.1105 <kaustubhc.1105@gmail.com>
</commit_message>
<xml_diff>
--- a/docs/PW25_BJD_05_Phase3_Review1.pptx
+++ b/docs/PW25_BJD_05_Phase3_Review1.pptx
@@ -19392,6 +19392,15 @@
             </a:pPr>
             <a:r>
               <a:rPr sz="1300" b="0"/>
+              <a:t>•  Results-assembly module — schema-hard-fail assembler (9/9 pytest green) that recomputes every reported number straight from the per-utterance CSVs and cross-checks it against each summary JSON</a:t>
+            </a:r>
+          </a:p>
+          <a:p>
+            <a:pPr>
+              <a:buNone/>
+            </a:pPr>
+            <a:r>
+              <a:rPr sz="1300" b="0"/>
               <a:t>•  Side-quest module — on-policy distillation (whisper-tiny ← whisper-large-v3) PoC on Modal, parked as a future direction</a:t>
             </a:r>
           </a:p>
@@ -20105,7 +20114,7 @@
                         <a:defRPr sz="1150"/>
                       </a:pPr>
                       <a:r>
-                        <a:t>Schema-validated results assembler; receipts pack (Saaras/ASR-FAIRBENCH/clinical-audit sources); report fixes</a:t>
+                        <a:t>Schema-hard-fail results assembler (9/9 tests green, reproduces all 6 rows exactly); 3-source receipts pack (PDF); fixed the HuBERT-row and [17]-citation report bugs</a:t>
                       </a:r>
                     </a:p>
                   </a:txBody>
@@ -20120,7 +20129,7 @@
                         <a:defRPr sz="1150"/>
                       </a:pPr>
                       <a:r>
-                        <a:t>In progress</a:t>
+                        <a:t>Complete</a:t>
                       </a:r>
                     </a:p>
                   </a:txBody>
@@ -20219,7 +20228,7 @@
               <a:defRPr sz="1100" i="1"/>
             </a:pPr>
             <a:r>
-              <a:t>Note: given the review deadline, Kaustubh personally ran all six audit systems (including the Whisper-family and external-API tracks) on Modal + the vendor APIs; ownership above reflects the planned task split and hand-off documentation, which the team is now reconciling in parallel.</a:t>
+              <a:t>Note: given the review deadline, Kaustubh personally ran all six audit systems (including the Whisper-family and external-API tracks) and completed the assembler/receipts/report-fix tasks on Modal + the vendor APIs; ownership above reflects the planned task split and hand-off documentation, which the team is now reconciling in parallel.</a:t>
             </a:r>
           </a:p>
         </p:txBody>

</xml_diff>